<commit_message>
fix: rebuild 2026-06-21 slides with Noto Sans JP
</commit_message>
<xml_diff>
--- a/presentations/day_slides/downloads/day_slide_2026_06_21_japan_ai_strategy_2040.pptx
+++ b/presentations/day_slides/downloads/day_slide_2026_06_21_japan_ai_strategy_2040.pptx
@@ -3104,7 +3104,7 @@
       <p:grpSpPr/>
       <p:pic>
         <p:nvPicPr>
-          <p:cNvPr id="2" name="Picture 1" descr="01-title.png"/>
+          <p:cNvPr id="2" name="Picture 1" descr="01.png"/>
           <p:cNvPicPr>
             <a:picLocks noChangeAspect="1"/>
           </p:cNvPicPr>
@@ -3146,7 +3146,7 @@
       <p:grpSpPr/>
       <p:pic>
         <p:nvPicPr>
-          <p:cNvPr id="2" name="Picture 1" descr="10-normal.png"/>
+          <p:cNvPr id="2" name="Picture 1" descr="10.png"/>
           <p:cNvPicPr>
             <a:picLocks noChangeAspect="1"/>
           </p:cNvPicPr>
@@ -3188,7 +3188,7 @@
       <p:grpSpPr/>
       <p:pic>
         <p:nvPicPr>
-          <p:cNvPr id="2" name="Picture 1" descr="11-normal.png"/>
+          <p:cNvPr id="2" name="Picture 1" descr="11.png"/>
           <p:cNvPicPr>
             <a:picLocks noChangeAspect="1"/>
           </p:cNvPicPr>
@@ -3230,7 +3230,7 @@
       <p:grpSpPr/>
       <p:pic>
         <p:nvPicPr>
-          <p:cNvPr id="2" name="Picture 1" descr="12-normal.png"/>
+          <p:cNvPr id="2" name="Picture 1" descr="12.png"/>
           <p:cNvPicPr>
             <a:picLocks noChangeAspect="1"/>
           </p:cNvPicPr>
@@ -3272,7 +3272,7 @@
       <p:grpSpPr/>
       <p:pic>
         <p:nvPicPr>
-          <p:cNvPr id="2" name="Picture 1" descr="13-normal.png"/>
+          <p:cNvPr id="2" name="Picture 1" descr="13.png"/>
           <p:cNvPicPr>
             <a:picLocks noChangeAspect="1"/>
           </p:cNvPicPr>
@@ -3314,7 +3314,7 @@
       <p:grpSpPr/>
       <p:pic>
         <p:nvPicPr>
-          <p:cNvPr id="2" name="Picture 1" descr="14-normal.png"/>
+          <p:cNvPr id="2" name="Picture 1" descr="14.png"/>
           <p:cNvPicPr>
             <a:picLocks noChangeAspect="1"/>
           </p:cNvPicPr>
@@ -3356,7 +3356,7 @@
       <p:grpSpPr/>
       <p:pic>
         <p:nvPicPr>
-          <p:cNvPr id="2" name="Picture 1" descr="15-normal.png"/>
+          <p:cNvPr id="2" name="Picture 1" descr="15.png"/>
           <p:cNvPicPr>
             <a:picLocks noChangeAspect="1"/>
           </p:cNvPicPr>
@@ -3398,7 +3398,7 @@
       <p:grpSpPr/>
       <p:pic>
         <p:nvPicPr>
-          <p:cNvPr id="2" name="Picture 1" descr="02-normal.png"/>
+          <p:cNvPr id="2" name="Picture 1" descr="02.png"/>
           <p:cNvPicPr>
             <a:picLocks noChangeAspect="1"/>
           </p:cNvPicPr>
@@ -3440,7 +3440,7 @@
       <p:grpSpPr/>
       <p:pic>
         <p:nvPicPr>
-          <p:cNvPr id="2" name="Picture 1" descr="03-normal.png"/>
+          <p:cNvPr id="2" name="Picture 1" descr="03.png"/>
           <p:cNvPicPr>
             <a:picLocks noChangeAspect="1"/>
           </p:cNvPicPr>
@@ -3482,7 +3482,7 @@
       <p:grpSpPr/>
       <p:pic>
         <p:nvPicPr>
-          <p:cNvPr id="2" name="Picture 1" descr="04-normal.png"/>
+          <p:cNvPr id="2" name="Picture 1" descr="04.png"/>
           <p:cNvPicPr>
             <a:picLocks noChangeAspect="1"/>
           </p:cNvPicPr>
@@ -3524,7 +3524,7 @@
       <p:grpSpPr/>
       <p:pic>
         <p:nvPicPr>
-          <p:cNvPr id="2" name="Picture 1" descr="05-normal.png"/>
+          <p:cNvPr id="2" name="Picture 1" descr="05.png"/>
           <p:cNvPicPr>
             <a:picLocks noChangeAspect="1"/>
           </p:cNvPicPr>
@@ -3566,7 +3566,7 @@
       <p:grpSpPr/>
       <p:pic>
         <p:nvPicPr>
-          <p:cNvPr id="2" name="Picture 1" descr="06-normal.png"/>
+          <p:cNvPr id="2" name="Picture 1" descr="06.png"/>
           <p:cNvPicPr>
             <a:picLocks noChangeAspect="1"/>
           </p:cNvPicPr>
@@ -3608,7 +3608,7 @@
       <p:grpSpPr/>
       <p:pic>
         <p:nvPicPr>
-          <p:cNvPr id="2" name="Picture 1" descr="07-normal.png"/>
+          <p:cNvPr id="2" name="Picture 1" descr="07.png"/>
           <p:cNvPicPr>
             <a:picLocks noChangeAspect="1"/>
           </p:cNvPicPr>
@@ -3650,7 +3650,7 @@
       <p:grpSpPr/>
       <p:pic>
         <p:nvPicPr>
-          <p:cNvPr id="2" name="Picture 1" descr="08-normal.png"/>
+          <p:cNvPr id="2" name="Picture 1" descr="08.png"/>
           <p:cNvPicPr>
             <a:picLocks noChangeAspect="1"/>
           </p:cNvPicPr>
@@ -3692,7 +3692,7 @@
       <p:grpSpPr/>
       <p:pic>
         <p:nvPicPr>
-          <p:cNvPr id="2" name="Picture 1" descr="09-normal.png"/>
+          <p:cNvPr id="2" name="Picture 1" descr="09.png"/>
           <p:cNvPicPr>
             <a:picLocks noChangeAspect="1"/>
           </p:cNvPicPr>

</xml_diff>